<commit_message>
L05: republish at 35 slides, the deck the room gets today
Replaces Sunday's 31-slide copy. Since then: the opening reworked onto
Lab01's choosers table and diagram with the six steps and the repair
insertion; no claim of a fallback recording; the chat break anchored on
Aider rather than a design nobody has yet; the priority request credited
to lesson three; the approval gate as a shape they were handed; the
milestones-to-rungs bridge; the who-chooses recap; and the repair
mechanism said concretely in the notes. Exports verified against the
source by page and slide count before copying.

Claude-Session: https://claude.ai/code/session_01QALchBYHfjmrqAeXPjxTh7
</commit_message>
<xml_diff>
--- a/lectures/L05/slides.pptx
+++ b/lectures/L05/slides.pptx
@@ -37,9 +37,12 @@
     <p:sldId id="285" r:id="rId31"/>
     <p:sldId id="286" r:id="rId32"/>
     <p:sldId id="287" r:id="rId33"/>
+    <p:sldId id="288" r:id="rId34"/>
+    <p:sldId id="289" r:id="rId35"/>
+    <p:sldId id="290" r:id="rId36"/>
   </p:sldIdLst>
   <p:notesMasterIdLst>
-    <p:notesMasterId r:id="rId34"/>
+    <p:notesMasterId r:id="rId37"/>
   </p:notesMasterIdLst>
   <p:sldSz cx="9334500" cy="5248275"/>
   <p:notesSz cx="5248275" cy="9334500"/>
@@ -624,7 +627,9 @@
           <a:p>
             <a:r>
               <a:rPr lang="en-US" dirty="0"/>
-              <a:t>Read them once. The next slide is where the work happens, so do not linger.</a:t>
+              <a:t>This trade is the entire gradient. Everything else is detail.
+Do not quantify it. Any multiple you say out loud will be wrong by next month
+and somebody will quote it back to you.</a:t>
             </a:r>
             <a:endParaRPr lang="en-US" dirty="0"/>
           </a:p>
@@ -667,6 +672,273 @@
 </file>
 
 <file path=ppt/notesSlides/notesSlide11.xml><?xml version="1.0" encoding="utf-8"?>
+<p:notes xmlns:a="http://schemas.openxmlformats.org/drawingml/2006/main" xmlns:r="http://schemas.openxmlformats.org/officeDocument/2006/relationships" xmlns:p="http://schemas.openxmlformats.org/presentationml/2006/main">
+  <p:cSld>
+    <p:spTree>
+      <p:nvGrpSpPr>
+        <p:cNvPr id="1" name=""/>
+        <p:cNvGrpSpPr/>
+        <p:nvPr/>
+      </p:nvGrpSpPr>
+      <p:grpSpPr>
+        <a:xfrm>
+          <a:off x="0" y="0"/>
+          <a:ext cx="0" cy="0"/>
+          <a:chOff x="0" y="0"/>
+          <a:chExt cx="0" cy="0"/>
+        </a:xfrm>
+      </p:grpSpPr>
+      <p:sp>
+        <p:nvSpPr>
+          <p:cNvPr id="2" name="Slide Image Placeholder 1"/>
+          <p:cNvSpPr>
+            <a:spLocks noGrp="1" noRot="1" noChangeAspect="1"/>
+          </p:cNvSpPr>
+          <p:nvPr>
+            <p:ph type="sldImg"/>
+          </p:nvPr>
+        </p:nvSpPr>
+        <p:spPr/>
+      </p:sp>
+      <p:sp>
+        <p:nvSpPr>
+          <p:cNvPr id="3" name="Notes Placeholder 2"/>
+          <p:cNvSpPr>
+            <a:spLocks noGrp="1"/>
+          </p:cNvSpPr>
+          <p:nvPr>
+            <p:ph type="body" idx="1"/>
+          </p:nvPr>
+        </p:nvSpPr>
+        <p:spPr/>
+        <p:txBody>
+          <a:bodyPr/>
+          <a:lstStyle/>
+          <a:p>
+            <a:r>
+              <a:rPr lang="en-US" dirty="0"/>
+              <a:t>The reflex this is aimed at: reaching for the most autonomous tool available
+because it is the most autonomous tool available.
+Ask when they would rather have the bounded version. Answers you are hoping
+for involve knowing exactly what to change, or a blast radius they care about.</a:t>
+            </a:r>
+            <a:endParaRPr lang="en-US" dirty="0"/>
+          </a:p>
+        </p:txBody>
+      </p:sp>
+      <p:sp>
+        <p:nvSpPr>
+          <p:cNvPr id="4" name="Slide Number Placeholder 3"/>
+          <p:cNvSpPr>
+            <a:spLocks noGrp="1"/>
+          </p:cNvSpPr>
+          <p:nvPr>
+            <p:ph type="sldNum" sz="quarter" idx="10"/>
+          </p:nvPr>
+        </p:nvSpPr>
+        <p:spPr/>
+        <p:txBody>
+          <a:bodyPr/>
+          <a:lstStyle/>
+          <a:p>
+            <a:fld id="{F7021451-1387-4CA6-816F-3879F97B5CBC}" type="slidenum">
+              <a:rPr lang="en-US"/>
+              <a:t>11</a:t>
+            </a:fld>
+            <a:endParaRPr lang="en-US"/>
+          </a:p>
+        </p:txBody>
+      </p:sp>
+    </p:spTree>
+    <p:extLst>
+      <p:ext uri="{BB962C8B-B14F-4D97-AF65-F5344CB8AC3E}">
+        <p14:creationId xmlns:p14="http://schemas.microsoft.com/office/powerpoint/2010/main" val="1024086991"/>
+      </p:ext>
+    </p:extLst>
+  </p:cSld>
+  <p:clrMapOvr>
+    <a:masterClrMapping/>
+  </p:clrMapOvr>
+</p:notes>
+</file>
+
+<file path=ppt/notesSlides/notesSlide12.xml><?xml version="1.0" encoding="utf-8"?>
+<p:notes xmlns:a="http://schemas.openxmlformats.org/drawingml/2006/main" xmlns:r="http://schemas.openxmlformats.org/officeDocument/2006/relationships" xmlns:p="http://schemas.openxmlformats.org/presentationml/2006/main">
+  <p:cSld>
+    <p:spTree>
+      <p:nvGrpSpPr>
+        <p:cNvPr id="1" name=""/>
+        <p:cNvGrpSpPr/>
+        <p:nvPr/>
+      </p:nvGrpSpPr>
+      <p:grpSpPr>
+        <a:xfrm>
+          <a:off x="0" y="0"/>
+          <a:ext cx="0" cy="0"/>
+          <a:chOff x="0" y="0"/>
+          <a:chExt cx="0" cy="0"/>
+        </a:xfrm>
+      </p:grpSpPr>
+      <p:sp>
+        <p:nvSpPr>
+          <p:cNvPr id="2" name="Slide Image Placeholder 1"/>
+          <p:cNvSpPr>
+            <a:spLocks noGrp="1" noRot="1" noChangeAspect="1"/>
+          </p:cNvSpPr>
+          <p:nvPr>
+            <p:ph type="sldImg"/>
+          </p:nvPr>
+        </p:nvSpPr>
+        <p:spPr/>
+      </p:sp>
+      <p:sp>
+        <p:nvSpPr>
+          <p:cNvPr id="3" name="Notes Placeholder 2"/>
+          <p:cNvSpPr>
+            <a:spLocks noGrp="1"/>
+          </p:cNvSpPr>
+          <p:nvPr>
+            <p:ph type="body" idx="1"/>
+          </p:nvPr>
+        </p:nvSpPr>
+        <p:spPr/>
+        <p:txBody>
+          <a:bodyPr/>
+          <a:lstStyle/>
+          <a:p>
+            <a:r>
+              <a:rPr lang="en-US" dirty="0"/>
+              <a:t/>
+            </a:r>
+            <a:endParaRPr lang="en-US" dirty="0"/>
+          </a:p>
+        </p:txBody>
+      </p:sp>
+      <p:sp>
+        <p:nvSpPr>
+          <p:cNvPr id="4" name="Slide Number Placeholder 3"/>
+          <p:cNvSpPr>
+            <a:spLocks noGrp="1"/>
+          </p:cNvSpPr>
+          <p:nvPr>
+            <p:ph type="sldNum" sz="quarter" idx="10"/>
+          </p:nvPr>
+        </p:nvSpPr>
+        <p:spPr/>
+        <p:txBody>
+          <a:bodyPr/>
+          <a:lstStyle/>
+          <a:p>
+            <a:fld id="{F7021451-1387-4CA6-816F-3879F97B5CBC}" type="slidenum">
+              <a:rPr lang="en-US"/>
+              <a:t>12</a:t>
+            </a:fld>
+            <a:endParaRPr lang="en-US"/>
+          </a:p>
+        </p:txBody>
+      </p:sp>
+    </p:spTree>
+    <p:extLst>
+      <p:ext uri="{BB962C8B-B14F-4D97-AF65-F5344CB8AC3E}">
+        <p14:creationId xmlns:p14="http://schemas.microsoft.com/office/powerpoint/2010/main" val="1024086991"/>
+      </p:ext>
+    </p:extLst>
+  </p:cSld>
+  <p:clrMapOvr>
+    <a:masterClrMapping/>
+  </p:clrMapOvr>
+</p:notes>
+</file>
+
+<file path=ppt/notesSlides/notesSlide13.xml><?xml version="1.0" encoding="utf-8"?>
+<p:notes xmlns:a="http://schemas.openxmlformats.org/drawingml/2006/main" xmlns:r="http://schemas.openxmlformats.org/officeDocument/2006/relationships" xmlns:p="http://schemas.openxmlformats.org/presentationml/2006/main">
+  <p:cSld>
+    <p:spTree>
+      <p:nvGrpSpPr>
+        <p:cNvPr id="1" name=""/>
+        <p:cNvGrpSpPr/>
+        <p:nvPr/>
+      </p:nvGrpSpPr>
+      <p:grpSpPr>
+        <a:xfrm>
+          <a:off x="0" y="0"/>
+          <a:ext cx="0" cy="0"/>
+          <a:chOff x="0" y="0"/>
+          <a:chExt cx="0" cy="0"/>
+        </a:xfrm>
+      </p:grpSpPr>
+      <p:sp>
+        <p:nvSpPr>
+          <p:cNvPr id="2" name="Slide Image Placeholder 1"/>
+          <p:cNvSpPr>
+            <a:spLocks noGrp="1" noRot="1" noChangeAspect="1"/>
+          </p:cNvSpPr>
+          <p:nvPr>
+            <p:ph type="sldImg"/>
+          </p:nvPr>
+        </p:nvSpPr>
+        <p:spPr/>
+      </p:sp>
+      <p:sp>
+        <p:nvSpPr>
+          <p:cNvPr id="3" name="Notes Placeholder 2"/>
+          <p:cNvSpPr>
+            <a:spLocks noGrp="1"/>
+          </p:cNvSpPr>
+          <p:nvPr>
+            <p:ph type="body" idx="1"/>
+          </p:nvPr>
+        </p:nvSpPr>
+        <p:spPr/>
+        <p:txBody>
+          <a:bodyPr/>
+          <a:lstStyle/>
+          <a:p>
+            <a:r>
+              <a:rPr lang="en-US" dirty="0"/>
+              <a:t>Read them once. The next slide is where the work happens, so do not linger.</a:t>
+            </a:r>
+            <a:endParaRPr lang="en-US" dirty="0"/>
+          </a:p>
+        </p:txBody>
+      </p:sp>
+      <p:sp>
+        <p:nvSpPr>
+          <p:cNvPr id="4" name="Slide Number Placeholder 3"/>
+          <p:cNvSpPr>
+            <a:spLocks noGrp="1"/>
+          </p:cNvSpPr>
+          <p:nvPr>
+            <p:ph type="sldNum" sz="quarter" idx="10"/>
+          </p:nvPr>
+        </p:nvSpPr>
+        <p:spPr/>
+        <p:txBody>
+          <a:bodyPr/>
+          <a:lstStyle/>
+          <a:p>
+            <a:fld id="{F7021451-1387-4CA6-816F-3879F97B5CBC}" type="slidenum">
+              <a:rPr lang="en-US"/>
+              <a:t>13</a:t>
+            </a:fld>
+            <a:endParaRPr lang="en-US"/>
+          </a:p>
+        </p:txBody>
+      </p:sp>
+    </p:spTree>
+    <p:extLst>
+      <p:ext uri="{BB962C8B-B14F-4D97-AF65-F5344CB8AC3E}">
+        <p14:creationId xmlns:p14="http://schemas.microsoft.com/office/powerpoint/2010/main" val="1024086991"/>
+      </p:ext>
+    </p:extLst>
+  </p:cSld>
+  <p:clrMapOvr>
+    <a:masterClrMapping/>
+  </p:clrMapOvr>
+</p:notes>
+</file>
+
+<file path=ppt/notesSlides/notesSlide14.xml><?xml version="1.0" encoding="utf-8"?>
 <p:notes xmlns:a="http://schemas.openxmlformats.org/drawingml/2006/main" xmlns:r="http://schemas.openxmlformats.org/officeDocument/2006/relationships" xmlns:p="http://schemas.openxmlformats.org/presentationml/2006/main">
   <p:cSld>
     <p:spTree>
@@ -738,7 +1010,7 @@
           <a:p>
             <a:fld id="{F7021451-1387-4CA6-816F-3879F97B5CBC}" type="slidenum">
               <a:rPr lang="en-US"/>
-              <a:t>11</a:t>
+              <a:t>14</a:t>
             </a:fld>
             <a:endParaRPr lang="en-US"/>
           </a:p>
@@ -757,7 +1029,7 @@
 </p:notes>
 </file>
 
-<file path=ppt/notesSlides/notesSlide12.xml><?xml version="1.0" encoding="utf-8"?>
+<file path=ppt/notesSlides/notesSlide15.xml><?xml version="1.0" encoding="utf-8"?>
 <p:notes xmlns:a="http://schemas.openxmlformats.org/drawingml/2006/main" xmlns:r="http://schemas.openxmlformats.org/officeDocument/2006/relationships" xmlns:p="http://schemas.openxmlformats.org/presentationml/2006/main">
   <p:cSld>
     <p:spTree>
@@ -804,7 +1076,12 @@
             <a:r>
               <a:rPr lang="en-US" dirty="0"/>
               <a:t>Pause here. This is the sentence the lecture turns on.
-Not which primitives exist. Which of them the human still holds.</a:t>
+Not which primitives exist. Which of them the human still holds.
+The six steps, for the callback: 1 assemble, you and Aider per the table.
+2 answer, the model, text out. 3 parse, Aider by a fixed rule. 4 apply,
+Aider, or it refuses. 5 repair, only if 4 failed, and it re-enters at 2.
+6 commit, Aider, every time. One of six belongs to the model. At every other
+step the chooser is you or a rule somebody wrote down in advance.</a:t>
             </a:r>
             <a:endParaRPr lang="en-US" dirty="0"/>
           </a:p>
@@ -827,7 +1104,7 @@
           <a:p>
             <a:fld id="{F7021451-1387-4CA6-816F-3879F97B5CBC}" type="slidenum">
               <a:rPr lang="en-US"/>
-              <a:t>12</a:t>
+              <a:t>15</a:t>
             </a:fld>
             <a:endParaRPr lang="en-US"/>
           </a:p>
@@ -846,7 +1123,7 @@
 </p:notes>
 </file>
 
-<file path=ppt/notesSlides/notesSlide13.xml><?xml version="1.0" encoding="utf-8"?>
+<file path=ppt/notesSlides/notesSlide16.xml><?xml version="1.0" encoding="utf-8"?>
 <p:notes xmlns:a="http://schemas.openxmlformats.org/drawingml/2006/main" xmlns:r="http://schemas.openxmlformats.org/officeDocument/2006/relationships" xmlns:p="http://schemas.openxmlformats.org/presentationml/2006/main">
   <p:cSld>
     <p:spTree>
@@ -917,7 +1194,7 @@
           <a:p>
             <a:fld id="{F7021451-1387-4CA6-816F-3879F97B5CBC}" type="slidenum">
               <a:rPr lang="en-US"/>
-              <a:t>13</a:t>
+              <a:t>16</a:t>
             </a:fld>
             <a:endParaRPr lang="en-US"/>
           </a:p>
@@ -936,7 +1213,7 @@
 </p:notes>
 </file>
 
-<file path=ppt/notesSlides/notesSlide14.xml><?xml version="1.0" encoding="utf-8"?>
+<file path=ppt/notesSlides/notesSlide17.xml><?xml version="1.0" encoding="utf-8"?>
 <p:notes xmlns:a="http://schemas.openxmlformats.org/drawingml/2006/main" xmlns:r="http://schemas.openxmlformats.org/officeDocument/2006/relationships" xmlns:p="http://schemas.openxmlformats.org/presentationml/2006/main">
   <p:cSld>
     <p:spTree>
@@ -1005,7 +1282,7 @@
           <a:p>
             <a:fld id="{F7021451-1387-4CA6-816F-3879F97B5CBC}" type="slidenum">
               <a:rPr lang="en-US"/>
-              <a:t>14</a:t>
+              <a:t>17</a:t>
             </a:fld>
             <a:endParaRPr lang="en-US"/>
           </a:p>
@@ -1024,7 +1301,7 @@
 </p:notes>
 </file>
 
-<file path=ppt/notesSlides/notesSlide15.xml><?xml version="1.0" encoding="utf-8"?>
+<file path=ppt/notesSlides/notesSlide18.xml><?xml version="1.0" encoding="utf-8"?>
 <p:notes xmlns:a="http://schemas.openxmlformats.org/drawingml/2006/main" xmlns:r="http://schemas.openxmlformats.org/officeDocument/2006/relationships" xmlns:p="http://schemas.openxmlformats.org/presentationml/2006/main">
   <p:cSld>
     <p:spTree>
@@ -1099,7 +1376,7 @@
           <a:p>
             <a:fld id="{F7021451-1387-4CA6-816F-3879F97B5CBC}" type="slidenum">
               <a:rPr lang="en-US"/>
-              <a:t>15</a:t>
+              <a:t>18</a:t>
             </a:fld>
             <a:endParaRPr lang="en-US"/>
           </a:p>
@@ -1118,7 +1395,7 @@
 </p:notes>
 </file>
 
-<file path=ppt/notesSlides/notesSlide16.xml><?xml version="1.0" encoding="utf-8"?>
+<file path=ppt/notesSlides/notesSlide19.xml><?xml version="1.0" encoding="utf-8"?>
 <p:notes xmlns:a="http://schemas.openxmlformats.org/drawingml/2006/main" xmlns:r="http://schemas.openxmlformats.org/officeDocument/2006/relationships" xmlns:p="http://schemas.openxmlformats.org/presentationml/2006/main">
   <p:cSld>
     <p:spTree>
@@ -1192,7 +1469,7 @@
           <a:p>
             <a:fld id="{F7021451-1387-4CA6-816F-3879F97B5CBC}" type="slidenum">
               <a:rPr lang="en-US"/>
-              <a:t>16</a:t>
+              <a:t>19</a:t>
             </a:fld>
             <a:endParaRPr lang="en-US"/>
           </a:p>
@@ -1211,7 +1488,100 @@
 </p:notes>
 </file>
 
-<file path=ppt/notesSlides/notesSlide17.xml><?xml version="1.0" encoding="utf-8"?>
+<file path=ppt/notesSlides/notesSlide2.xml><?xml version="1.0" encoding="utf-8"?>
+<p:notes xmlns:a="http://schemas.openxmlformats.org/drawingml/2006/main" xmlns:r="http://schemas.openxmlformats.org/officeDocument/2006/relationships" xmlns:p="http://schemas.openxmlformats.org/presentationml/2006/main">
+  <p:cSld>
+    <p:spTree>
+      <p:nvGrpSpPr>
+        <p:cNvPr id="1" name=""/>
+        <p:cNvGrpSpPr/>
+        <p:nvPr/>
+      </p:nvGrpSpPr>
+      <p:grpSpPr>
+        <a:xfrm>
+          <a:off x="0" y="0"/>
+          <a:ext cx="0" cy="0"/>
+          <a:chOff x="0" y="0"/>
+          <a:chExt cx="0" cy="0"/>
+        </a:xfrm>
+      </p:grpSpPr>
+      <p:sp>
+        <p:nvSpPr>
+          <p:cNvPr id="2" name="Slide Image Placeholder 1"/>
+          <p:cNvSpPr>
+            <a:spLocks noGrp="1" noRot="1" noChangeAspect="1"/>
+          </p:cNvSpPr>
+          <p:nvPr>
+            <p:ph type="sldImg"/>
+          </p:nvPr>
+        </p:nvSpPr>
+        <p:spPr/>
+      </p:sp>
+      <p:sp>
+        <p:nvSpPr>
+          <p:cNvPr id="3" name="Notes Placeholder 2"/>
+          <p:cNvSpPr>
+            <a:spLocks noGrp="1"/>
+          </p:cNvSpPr>
+          <p:nvPr>
+            <p:ph type="body" idx="1"/>
+          </p:nvPr>
+        </p:nvSpPr>
+        <p:spPr/>
+        <p:txBody>
+          <a:bodyPr/>
+          <a:lstStyle/>
+          <a:p>
+            <a:r>
+              <a:rPr lang="en-US" dirty="0"/>
+              <a:t>Thirty seconds of recall, no more. Monday's room did this yesterday, Tuesday's
+finished ninety minutes ago, so this is a pointer and not a recap.
+Lab01's table, unchanged. It is here because the whole lecture is about that
+right-hand column, and because the answer they gave yesterday is about to get
+one row longer.
+Read down the right side and stop. Do not answer the next slide.</a:t>
+            </a:r>
+            <a:endParaRPr lang="en-US" dirty="0"/>
+          </a:p>
+        </p:txBody>
+      </p:sp>
+      <p:sp>
+        <p:nvSpPr>
+          <p:cNvPr id="4" name="Slide Number Placeholder 3"/>
+          <p:cNvSpPr>
+            <a:spLocks noGrp="1"/>
+          </p:cNvSpPr>
+          <p:nvPr>
+            <p:ph type="sldNum" sz="quarter" idx="10"/>
+          </p:nvPr>
+        </p:nvSpPr>
+        <p:spPr/>
+        <p:txBody>
+          <a:bodyPr/>
+          <a:lstStyle/>
+          <a:p>
+            <a:fld id="{F7021451-1387-4CA6-816F-3879F97B5CBC}" type="slidenum">
+              <a:rPr lang="en-US"/>
+              <a:t>2</a:t>
+            </a:fld>
+            <a:endParaRPr lang="en-US"/>
+          </a:p>
+        </p:txBody>
+      </p:sp>
+    </p:spTree>
+    <p:extLst>
+      <p:ext uri="{BB962C8B-B14F-4D97-AF65-F5344CB8AC3E}">
+        <p14:creationId xmlns:p14="http://schemas.microsoft.com/office/powerpoint/2010/main" val="1024086991"/>
+      </p:ext>
+    </p:extLst>
+  </p:cSld>
+  <p:clrMapOvr>
+    <a:masterClrMapping/>
+  </p:clrMapOvr>
+</p:notes>
+</file>
+
+<file path=ppt/notesSlides/notesSlide20.xml><?xml version="1.0" encoding="utf-8"?>
 <p:notes xmlns:a="http://schemas.openxmlformats.org/drawingml/2006/main" xmlns:r="http://schemas.openxmlformats.org/officeDocument/2006/relationships" xmlns:p="http://schemas.openxmlformats.org/presentationml/2006/main">
   <p:cSld>
     <p:spTree>
@@ -1280,7 +1650,7 @@
           <a:p>
             <a:fld id="{F7021451-1387-4CA6-816F-3879F97B5CBC}" type="slidenum">
               <a:rPr lang="en-US"/>
-              <a:t>17</a:t>
+              <a:t>20</a:t>
             </a:fld>
             <a:endParaRPr lang="en-US"/>
           </a:p>
@@ -1299,7 +1669,7 @@
 </p:notes>
 </file>
 
-<file path=ppt/notesSlides/notesSlide18.xml><?xml version="1.0" encoding="utf-8"?>
+<file path=ppt/notesSlides/notesSlide21.xml><?xml version="1.0" encoding="utf-8"?>
 <p:notes xmlns:a="http://schemas.openxmlformats.org/drawingml/2006/main" xmlns:r="http://schemas.openxmlformats.org/officeDocument/2006/relationships" xmlns:p="http://schemas.openxmlformats.org/presentationml/2006/main">
   <p:cSld>
     <p:spTree>
@@ -1345,7 +1715,7 @@
           <a:p>
             <a:r>
               <a:rPr lang="en-US" dirty="0"/>
-              <a:t>Same request as Lab01, deliberately. One task at two rungs is the only honest
+              <a:t>Same request as lesson three, deliberately. One task at two rungs is the only honest
 comparison available in eighty minutes.
 Nobody needs the taskr recap. They have been living in it for two weeks.</a:t>
             </a:r>
@@ -1370,7 +1740,7 @@
           <a:p>
             <a:fld id="{F7021451-1387-4CA6-816F-3879F97B5CBC}" type="slidenum">
               <a:rPr lang="en-US"/>
-              <a:t>18</a:t>
+              <a:t>21</a:t>
             </a:fld>
             <a:endParaRPr lang="en-US"/>
           </a:p>
@@ -1389,7 +1759,7 @@
 </p:notes>
 </file>
 
-<file path=ppt/notesSlides/notesSlide19.xml><?xml version="1.0" encoding="utf-8"?>
+<file path=ppt/notesSlides/notesSlide22.xml><?xml version="1.0" encoding="utf-8"?>
 <p:notes xmlns:a="http://schemas.openxmlformats.org/drawingml/2006/main" xmlns:r="http://schemas.openxmlformats.org/officeDocument/2006/relationships" xmlns:p="http://schemas.openxmlformats.org/presentationml/2006/main">
   <p:cSld>
     <p:spTree>
@@ -1436,7 +1806,7 @@
             <a:r>
               <a:rPr lang="en-US" dirty="0"/>
               <a:t>Switch to the terminal here and drive it. Runbook in `assets/demo-runbook.md`;
-if the network is down, the recording is in `assets/demo-fallback.md`.
+there is no recording behind this, so if the network is down see `assets/demo-fallback.md`.
 Narrate the decisions, not the typing. Every time it picks a file, say that
 nobody told it to.
 Rehearse this before delivering. What it actually does today is a fact about
@@ -1463,7 +1833,7 @@
           <a:p>
             <a:fld id="{F7021451-1387-4CA6-816F-3879F97B5CBC}" type="slidenum">
               <a:rPr lang="en-US"/>
-              <a:t>19</a:t>
+              <a:t>22</a:t>
             </a:fld>
             <a:endParaRPr lang="en-US"/>
           </a:p>
@@ -1482,98 +1852,7 @@
 </p:notes>
 </file>
 
-<file path=ppt/notesSlides/notesSlide2.xml><?xml version="1.0" encoding="utf-8"?>
-<p:notes xmlns:a="http://schemas.openxmlformats.org/drawingml/2006/main" xmlns:r="http://schemas.openxmlformats.org/officeDocument/2006/relationships" xmlns:p="http://schemas.openxmlformats.org/presentationml/2006/main">
-  <p:cSld>
-    <p:spTree>
-      <p:nvGrpSpPr>
-        <p:cNvPr id="1" name=""/>
-        <p:cNvGrpSpPr/>
-        <p:nvPr/>
-      </p:nvGrpSpPr>
-      <p:grpSpPr>
-        <a:xfrm>
-          <a:off x="0" y="0"/>
-          <a:ext cx="0" cy="0"/>
-          <a:chOff x="0" y="0"/>
-          <a:chExt cx="0" cy="0"/>
-        </a:xfrm>
-      </p:grpSpPr>
-      <p:sp>
-        <p:nvSpPr>
-          <p:cNvPr id="2" name="Slide Image Placeholder 1"/>
-          <p:cNvSpPr>
-            <a:spLocks noGrp="1" noRot="1" noChangeAspect="1"/>
-          </p:cNvSpPr>
-          <p:nvPr>
-            <p:ph type="sldImg"/>
-          </p:nvPr>
-        </p:nvSpPr>
-        <p:spPr/>
-      </p:sp>
-      <p:sp>
-        <p:nvSpPr>
-          <p:cNvPr id="3" name="Notes Placeholder 2"/>
-          <p:cNvSpPr>
-            <a:spLocks noGrp="1"/>
-          </p:cNvSpPr>
-          <p:nvPr>
-            <p:ph type="body" idx="1"/>
-          </p:nvPr>
-        </p:nvSpPr>
-        <p:spPr/>
-        <p:txBody>
-          <a:bodyPr/>
-          <a:lstStyle/>
-          <a:p>
-            <a:r>
-              <a:rPr lang="en-US" dirty="0"/>
-              <a:t>Thirty seconds of recall, no more. Monday's room did this yesterday, Tuesday's
-finished ninety minutes ago, so this is a pointer and not a recap.
-If you want one answer out loud, ask which of the six steps belonged to the
-model. Step 2, and only step 2.</a:t>
-            </a:r>
-            <a:endParaRPr lang="en-US" dirty="0"/>
-          </a:p>
-        </p:txBody>
-      </p:sp>
-      <p:sp>
-        <p:nvSpPr>
-          <p:cNvPr id="4" name="Slide Number Placeholder 3"/>
-          <p:cNvSpPr>
-            <a:spLocks noGrp="1"/>
-          </p:cNvSpPr>
-          <p:nvPr>
-            <p:ph type="sldNum" sz="quarter" idx="10"/>
-          </p:nvPr>
-        </p:nvSpPr>
-        <p:spPr/>
-        <p:txBody>
-          <a:bodyPr/>
-          <a:lstStyle/>
-          <a:p>
-            <a:fld id="{F7021451-1387-4CA6-816F-3879F97B5CBC}" type="slidenum">
-              <a:rPr lang="en-US"/>
-              <a:t>2</a:t>
-            </a:fld>
-            <a:endParaRPr lang="en-US"/>
-          </a:p>
-        </p:txBody>
-      </p:sp>
-    </p:spTree>
-    <p:extLst>
-      <p:ext uri="{BB962C8B-B14F-4D97-AF65-F5344CB8AC3E}">
-        <p14:creationId xmlns:p14="http://schemas.microsoft.com/office/powerpoint/2010/main" val="1024086991"/>
-      </p:ext>
-    </p:extLst>
-  </p:cSld>
-  <p:clrMapOvr>
-    <a:masterClrMapping/>
-  </p:clrMapOvr>
-</p:notes>
-</file>
-
-<file path=ppt/notesSlides/notesSlide20.xml><?xml version="1.0" encoding="utf-8"?>
+<file path=ppt/notesSlides/notesSlide23.xml><?xml version="1.0" encoding="utf-8"?>
 <p:notes xmlns:a="http://schemas.openxmlformats.org/drawingml/2006/main" xmlns:r="http://schemas.openxmlformats.org/officeDocument/2006/relationships" xmlns:p="http://schemas.openxmlformats.org/presentationml/2006/main">
   <p:cSld>
     <p:spTree>
@@ -1645,7 +1924,7 @@
           <a:p>
             <a:fld id="{F7021451-1387-4CA6-816F-3879F97B5CBC}" type="slidenum">
               <a:rPr lang="en-US"/>
-              <a:t>20</a:t>
+              <a:t>23</a:t>
             </a:fld>
             <a:endParaRPr lang="en-US"/>
           </a:p>
@@ -1664,7 +1943,7 @@
 </p:notes>
 </file>
 
-<file path=ppt/notesSlides/notesSlide21.xml><?xml version="1.0" encoding="utf-8"?>
+<file path=ppt/notesSlides/notesSlide24.xml><?xml version="1.0" encoding="utf-8"?>
 <p:notes xmlns:a="http://schemas.openxmlformats.org/drawingml/2006/main" xmlns:r="http://schemas.openxmlformats.org/officeDocument/2006/relationships" xmlns:p="http://schemas.openxmlformats.org/presentationml/2006/main">
   <p:cSld>
     <p:spTree>
@@ -1736,7 +2015,7 @@
           <a:p>
             <a:fld id="{F7021451-1387-4CA6-816F-3879F97B5CBC}" type="slidenum">
               <a:rPr lang="en-US"/>
-              <a:t>21</a:t>
+              <a:t>24</a:t>
             </a:fld>
             <a:endParaRPr lang="en-US"/>
           </a:p>
@@ -1755,7 +2034,7 @@
 </p:notes>
 </file>
 
-<file path=ppt/notesSlides/notesSlide22.xml><?xml version="1.0" encoding="utf-8"?>
+<file path=ppt/notesSlides/notesSlide25.xml><?xml version="1.0" encoding="utf-8"?>
 <p:notes xmlns:a="http://schemas.openxmlformats.org/drawingml/2006/main" xmlns:r="http://schemas.openxmlformats.org/officeDocument/2006/relationships" xmlns:p="http://schemas.openxmlformats.org/presentationml/2006/main">
   <p:cSld>
     <p:spTree>
@@ -1824,7 +2103,7 @@
           <a:p>
             <a:fld id="{F7021451-1387-4CA6-816F-3879F97B5CBC}" type="slidenum">
               <a:rPr lang="en-US"/>
-              <a:t>22</a:t>
+              <a:t>25</a:t>
             </a:fld>
             <a:endParaRPr lang="en-US"/>
           </a:p>
@@ -1843,7 +2122,7 @@
 </p:notes>
 </file>
 
-<file path=ppt/notesSlides/notesSlide23.xml><?xml version="1.0" encoding="utf-8"?>
+<file path=ppt/notesSlides/notesSlide26.xml><?xml version="1.0" encoding="utf-8"?>
 <p:notes xmlns:a="http://schemas.openxmlformats.org/drawingml/2006/main" xmlns:r="http://schemas.openxmlformats.org/officeDocument/2006/relationships" xmlns:p="http://schemas.openxmlformats.org/presentationml/2006/main">
   <p:cSld>
     <p:spTree>
@@ -1915,7 +2194,7 @@
           <a:p>
             <a:fld id="{F7021451-1387-4CA6-816F-3879F97B5CBC}" type="slidenum">
               <a:rPr lang="en-US"/>
-              <a:t>23</a:t>
+              <a:t>26</a:t>
             </a:fld>
             <a:endParaRPr lang="en-US"/>
           </a:p>
@@ -1934,7 +2213,7 @@
 </p:notes>
 </file>
 
-<file path=ppt/notesSlides/notesSlide24.xml><?xml version="1.0" encoding="utf-8"?>
+<file path=ppt/notesSlides/notesSlide27.xml><?xml version="1.0" encoding="utf-8"?>
 <p:notes xmlns:a="http://schemas.openxmlformats.org/drawingml/2006/main" xmlns:r="http://schemas.openxmlformats.org/officeDocument/2006/relationships" xmlns:p="http://schemas.openxmlformats.org/presentationml/2006/main">
   <p:cSld>
     <p:spTree>
@@ -1980,8 +2259,9 @@
           <a:p>
             <a:r>
               <a:rPr lang="en-US" dirty="0"/>
-              <a:t>Tie it to their own specification explicitly. They wrote the approval gate last
-week and may not have noticed it was the same idea.
+              <a:t>Tie it to the specification they were handed: F6, preview, approval and
+application. Lab01's closing table already put it in front of them as the rule
+they will write.
 Do not answer the question on the slide. It is Analyze's, and Lab03's.</a:t>
             </a:r>
             <a:endParaRPr lang="en-US" dirty="0"/>
@@ -2005,7 +2285,7 @@
           <a:p>
             <a:fld id="{F7021451-1387-4CA6-816F-3879F97B5CBC}" type="slidenum">
               <a:rPr lang="en-US"/>
-              <a:t>24</a:t>
+              <a:t>27</a:t>
             </a:fld>
             <a:endParaRPr lang="en-US"/>
           </a:p>
@@ -2024,7 +2304,7 @@
 </p:notes>
 </file>
 
-<file path=ppt/notesSlides/notesSlide25.xml><?xml version="1.0" encoding="utf-8"?>
+<file path=ppt/notesSlides/notesSlide28.xml><?xml version="1.0" encoding="utf-8"?>
 <p:notes xmlns:a="http://schemas.openxmlformats.org/drawingml/2006/main" xmlns:r="http://schemas.openxmlformats.org/officeDocument/2006/relationships" xmlns:p="http://schemas.openxmlformats.org/presentationml/2006/main">
   <p:cSld>
     <p:spTree>
@@ -2096,7 +2376,7 @@
           <a:p>
             <a:fld id="{F7021451-1387-4CA6-816F-3879F97B5CBC}" type="slidenum">
               <a:rPr lang="en-US"/>
-              <a:t>25</a:t>
+              <a:t>28</a:t>
             </a:fld>
             <a:endParaRPr lang="en-US"/>
           </a:p>
@@ -2115,7 +2395,7 @@
 </p:notes>
 </file>
 
-<file path=ppt/notesSlides/notesSlide26.xml><?xml version="1.0" encoding="utf-8"?>
+<file path=ppt/notesSlides/notesSlide29.xml><?xml version="1.0" encoding="utf-8"?>
 <p:notes xmlns:a="http://schemas.openxmlformats.org/drawingml/2006/main" xmlns:r="http://schemas.openxmlformats.org/officeDocument/2006/relationships" xmlns:p="http://schemas.openxmlformats.org/presentationml/2006/main">
   <p:cSld>
     <p:spTree>
@@ -2187,7 +2467,7 @@
           <a:p>
             <a:fld id="{F7021451-1387-4CA6-816F-3879F97B5CBC}" type="slidenum">
               <a:rPr lang="en-US"/>
-              <a:t>26</a:t>
+              <a:t>29</a:t>
             </a:fld>
             <a:endParaRPr lang="en-US"/>
           </a:p>
@@ -2206,7 +2486,100 @@
 </p:notes>
 </file>
 
-<file path=ppt/notesSlides/notesSlide27.xml><?xml version="1.0" encoding="utf-8"?>
+<file path=ppt/notesSlides/notesSlide3.xml><?xml version="1.0" encoding="utf-8"?>
+<p:notes xmlns:a="http://schemas.openxmlformats.org/drawingml/2006/main" xmlns:r="http://schemas.openxmlformats.org/officeDocument/2006/relationships" xmlns:p="http://schemas.openxmlformats.org/presentationml/2006/main">
+  <p:cSld>
+    <p:spTree>
+      <p:nvGrpSpPr>
+        <p:cNvPr id="1" name=""/>
+        <p:cNvGrpSpPr/>
+        <p:nvPr/>
+      </p:nvGrpSpPr>
+      <p:grpSpPr>
+        <a:xfrm>
+          <a:off x="0" y="0"/>
+          <a:ext cx="0" cy="0"/>
+          <a:chOff x="0" y="0"/>
+          <a:chExt cx="0" cy="0"/>
+        </a:xfrm>
+      </p:grpSpPr>
+      <p:sp>
+        <p:nvSpPr>
+          <p:cNvPr id="2" name="Slide Image Placeholder 1"/>
+          <p:cNvSpPr>
+            <a:spLocks noGrp="1" noRot="1" noChangeAspect="1"/>
+          </p:cNvSpPr>
+          <p:nvPr>
+            <p:ph type="sldImg"/>
+          </p:nvPr>
+        </p:nvSpPr>
+        <p:spPr/>
+      </p:sp>
+      <p:sp>
+        <p:nvSpPr>
+          <p:cNvPr id="3" name="Notes Placeholder 2"/>
+          <p:cNvSpPr>
+            <a:spLocks noGrp="1"/>
+          </p:cNvSpPr>
+          <p:nvPr>
+            <p:ph type="body" idx="1"/>
+          </p:nvPr>
+        </p:nvSpPr>
+        <p:spPr/>
+        <p:txBody>
+          <a:bodyPr/>
+          <a:lstStyle/>
+          <a:p>
+            <a:r>
+              <a:rPr lang="en-US" dirty="0"/>
+              <a:t>Lab01's slide, as they saw it. Do not re-teach it: ask them to name the three
+boxes and move.
+The three boxes are five of the six steps, which is the point of putting it
+back up. Assemble the request. The model answers. Parse the reply and apply
+it. Record it. Nobody drew them as a numbered line yesterday, and the next
+slide does.</a:t>
+            </a:r>
+            <a:endParaRPr lang="en-US" dirty="0"/>
+          </a:p>
+        </p:txBody>
+      </p:sp>
+      <p:sp>
+        <p:nvSpPr>
+          <p:cNvPr id="4" name="Slide Number Placeholder 3"/>
+          <p:cNvSpPr>
+            <a:spLocks noGrp="1"/>
+          </p:cNvSpPr>
+          <p:nvPr>
+            <p:ph type="sldNum" sz="quarter" idx="10"/>
+          </p:nvPr>
+        </p:nvSpPr>
+        <p:spPr/>
+        <p:txBody>
+          <a:bodyPr/>
+          <a:lstStyle/>
+          <a:p>
+            <a:fld id="{F7021451-1387-4CA6-816F-3879F97B5CBC}" type="slidenum">
+              <a:rPr lang="en-US"/>
+              <a:t>3</a:t>
+            </a:fld>
+            <a:endParaRPr lang="en-US"/>
+          </a:p>
+        </p:txBody>
+      </p:sp>
+    </p:spTree>
+    <p:extLst>
+      <p:ext uri="{BB962C8B-B14F-4D97-AF65-F5344CB8AC3E}">
+        <p14:creationId xmlns:p14="http://schemas.microsoft.com/office/powerpoint/2010/main" val="1024086991"/>
+      </p:ext>
+    </p:extLst>
+  </p:cSld>
+  <p:clrMapOvr>
+    <a:masterClrMapping/>
+  </p:clrMapOvr>
+</p:notes>
+</file>
+
+<file path=ppt/notesSlides/notesSlide30.xml><?xml version="1.0" encoding="utf-8"?>
 <p:notes xmlns:a="http://schemas.openxmlformats.org/drawingml/2006/main" xmlns:r="http://schemas.openxmlformats.org/officeDocument/2006/relationships" xmlns:p="http://schemas.openxmlformats.org/presentationml/2006/main">
   <p:cSld>
     <p:spTree>
@@ -2277,7 +2650,7 @@
           <a:p>
             <a:fld id="{F7021451-1387-4CA6-816F-3879F97B5CBC}" type="slidenum">
               <a:rPr lang="en-US"/>
-              <a:t>27</a:t>
+              <a:t>30</a:t>
             </a:fld>
             <a:endParaRPr lang="en-US"/>
           </a:p>
@@ -2296,7 +2669,7 @@
 </p:notes>
 </file>
 
-<file path=ppt/notesSlides/notesSlide28.xml><?xml version="1.0" encoding="utf-8"?>
+<file path=ppt/notesSlides/notesSlide31.xml><?xml version="1.0" encoding="utf-8"?>
 <p:notes xmlns:a="http://schemas.openxmlformats.org/drawingml/2006/main" xmlns:r="http://schemas.openxmlformats.org/officeDocument/2006/relationships" xmlns:p="http://schemas.openxmlformats.org/presentationml/2006/main">
   <p:cSld>
     <p:spTree>
@@ -2367,7 +2740,7 @@
           <a:p>
             <a:fld id="{F7021451-1387-4CA6-816F-3879F97B5CBC}" type="slidenum">
               <a:rPr lang="en-US"/>
-              <a:t>28</a:t>
+              <a:t>31</a:t>
             </a:fld>
             <a:endParaRPr lang="en-US"/>
           </a:p>
@@ -2386,7 +2759,7 @@
 </p:notes>
 </file>
 
-<file path=ppt/notesSlides/notesSlide29.xml><?xml version="1.0" encoding="utf-8"?>
+<file path=ppt/notesSlides/notesSlide32.xml><?xml version="1.0" encoding="utf-8"?>
 <p:notes xmlns:a="http://schemas.openxmlformats.org/drawingml/2006/main" xmlns:r="http://schemas.openxmlformats.org/officeDocument/2006/relationships" xmlns:p="http://schemas.openxmlformats.org/presentationml/2006/main">
   <p:cSld>
     <p:spTree>
@@ -2458,7 +2831,7 @@
           <a:p>
             <a:fld id="{F7021451-1387-4CA6-816F-3879F97B5CBC}" type="slidenum">
               <a:rPr lang="en-US"/>
-              <a:t>29</a:t>
+              <a:t>32</a:t>
             </a:fld>
             <a:endParaRPr lang="en-US"/>
           </a:p>
@@ -2477,7 +2850,469 @@
 </p:notes>
 </file>
 
-<file path=ppt/notesSlides/notesSlide3.xml><?xml version="1.0" encoding="utf-8"?>
+<file path=ppt/notesSlides/notesSlide33.xml><?xml version="1.0" encoding="utf-8"?>
+<p:notes xmlns:a="http://schemas.openxmlformats.org/drawingml/2006/main" xmlns:r="http://schemas.openxmlformats.org/officeDocument/2006/relationships" xmlns:p="http://schemas.openxmlformats.org/presentationml/2006/main">
+  <p:cSld>
+    <p:spTree>
+      <p:nvGrpSpPr>
+        <p:cNvPr id="1" name=""/>
+        <p:cNvGrpSpPr/>
+        <p:nvPr/>
+      </p:nvGrpSpPr>
+      <p:grpSpPr>
+        <a:xfrm>
+          <a:off x="0" y="0"/>
+          <a:ext cx="0" cy="0"/>
+          <a:chOff x="0" y="0"/>
+          <a:chExt cx="0" cy="0"/>
+        </a:xfrm>
+      </p:grpSpPr>
+      <p:sp>
+        <p:nvSpPr>
+          <p:cNvPr id="2" name="Slide Image Placeholder 1"/>
+          <p:cNvSpPr>
+            <a:spLocks noGrp="1" noRot="1" noChangeAspect="1"/>
+          </p:cNvSpPr>
+          <p:nvPr>
+            <p:ph type="sldImg"/>
+          </p:nvPr>
+        </p:nvSpPr>
+        <p:spPr/>
+      </p:sp>
+      <p:sp>
+        <p:nvSpPr>
+          <p:cNvPr id="3" name="Notes Placeholder 2"/>
+          <p:cNvSpPr>
+            <a:spLocks noGrp="1"/>
+          </p:cNvSpPr>
+          <p:nvPr>
+            <p:ph type="body" idx="1"/>
+          </p:nvPr>
+        </p:nvSpPr>
+        <p:spPr/>
+        <p:txBody>
+          <a:bodyPr/>
+          <a:lstStyle/>
+          <a:p>
+            <a:r>
+              <a:rPr lang="en-US" dirty="0"/>
+              <a:t>Leave this up during questions. Number two is the one that comes back in
+Analyze, and number three is the one that makes them better engineers this
+week.</a:t>
+            </a:r>
+            <a:endParaRPr lang="en-US" dirty="0"/>
+          </a:p>
+        </p:txBody>
+      </p:sp>
+      <p:sp>
+        <p:nvSpPr>
+          <p:cNvPr id="4" name="Slide Number Placeholder 3"/>
+          <p:cNvSpPr>
+            <a:spLocks noGrp="1"/>
+          </p:cNvSpPr>
+          <p:nvPr>
+            <p:ph type="sldNum" sz="quarter" idx="10"/>
+          </p:nvPr>
+        </p:nvSpPr>
+        <p:spPr/>
+        <p:txBody>
+          <a:bodyPr/>
+          <a:lstStyle/>
+          <a:p>
+            <a:fld id="{F7021451-1387-4CA6-816F-3879F97B5CBC}" type="slidenum">
+              <a:rPr lang="en-US"/>
+              <a:t>33</a:t>
+            </a:fld>
+            <a:endParaRPr lang="en-US"/>
+          </a:p>
+        </p:txBody>
+      </p:sp>
+    </p:spTree>
+    <p:extLst>
+      <p:ext uri="{BB962C8B-B14F-4D97-AF65-F5344CB8AC3E}">
+        <p14:creationId xmlns:p14="http://schemas.microsoft.com/office/powerpoint/2010/main" val="1024086991"/>
+      </p:ext>
+    </p:extLst>
+  </p:cSld>
+  <p:clrMapOvr>
+    <a:masterClrMapping/>
+  </p:clrMapOvr>
+</p:notes>
+</file>
+
+<file path=ppt/notesSlides/notesSlide34.xml><?xml version="1.0" encoding="utf-8"?>
+<p:notes xmlns:a="http://schemas.openxmlformats.org/drawingml/2006/main" xmlns:r="http://schemas.openxmlformats.org/officeDocument/2006/relationships" xmlns:p="http://schemas.openxmlformats.org/presentationml/2006/main">
+  <p:cSld>
+    <p:spTree>
+      <p:nvGrpSpPr>
+        <p:cNvPr id="1" name=""/>
+        <p:cNvGrpSpPr/>
+        <p:nvPr/>
+      </p:nvGrpSpPr>
+      <p:grpSpPr>
+        <a:xfrm>
+          <a:off x="0" y="0"/>
+          <a:ext cx="0" cy="0"/>
+          <a:chOff x="0" y="0"/>
+          <a:chExt cx="0" cy="0"/>
+        </a:xfrm>
+      </p:grpSpPr>
+      <p:sp>
+        <p:nvSpPr>
+          <p:cNvPr id="2" name="Slide Image Placeholder 1"/>
+          <p:cNvSpPr>
+            <a:spLocks noGrp="1" noRot="1" noChangeAspect="1"/>
+          </p:cNvSpPr>
+          <p:nvPr>
+            <p:ph type="sldImg"/>
+          </p:nvPr>
+        </p:nvSpPr>
+        <p:spPr/>
+      </p:sp>
+      <p:sp>
+        <p:nvSpPr>
+          <p:cNvPr id="3" name="Notes Placeholder 2"/>
+          <p:cNvSpPr>
+            <a:spLocks noGrp="1"/>
+          </p:cNvSpPr>
+          <p:nvPr>
+            <p:ph type="body" idx="1"/>
+          </p:nvPr>
+        </p:nvSpPr>
+        <p:spPr/>
+        <p:txBody>
+          <a:bodyPr/>
+          <a:lstStyle/>
+          <a:p>
+            <a:r>
+              <a:rPr lang="en-US" dirty="0"/>
+              <a:t>The bridge. L06 closes Apply and hands over to Analyze, where they write the
+box from the harness slide rather than watching it work.</a:t>
+            </a:r>
+            <a:endParaRPr lang="en-US" dirty="0"/>
+          </a:p>
+        </p:txBody>
+      </p:sp>
+      <p:sp>
+        <p:nvSpPr>
+          <p:cNvPr id="4" name="Slide Number Placeholder 3"/>
+          <p:cNvSpPr>
+            <a:spLocks noGrp="1"/>
+          </p:cNvSpPr>
+          <p:nvPr>
+            <p:ph type="sldNum" sz="quarter" idx="10"/>
+          </p:nvPr>
+        </p:nvSpPr>
+        <p:spPr/>
+        <p:txBody>
+          <a:bodyPr/>
+          <a:lstStyle/>
+          <a:p>
+            <a:fld id="{F7021451-1387-4CA6-816F-3879F97B5CBC}" type="slidenum">
+              <a:rPr lang="en-US"/>
+              <a:t>34</a:t>
+            </a:fld>
+            <a:endParaRPr lang="en-US"/>
+          </a:p>
+        </p:txBody>
+      </p:sp>
+    </p:spTree>
+    <p:extLst>
+      <p:ext uri="{BB962C8B-B14F-4D97-AF65-F5344CB8AC3E}">
+        <p14:creationId xmlns:p14="http://schemas.microsoft.com/office/powerpoint/2010/main" val="1024086991"/>
+      </p:ext>
+    </p:extLst>
+  </p:cSld>
+  <p:clrMapOvr>
+    <a:masterClrMapping/>
+  </p:clrMapOvr>
+</p:notes>
+</file>
+
+<file path=ppt/notesSlides/notesSlide35.xml><?xml version="1.0" encoding="utf-8"?>
+<p:notes xmlns:a="http://schemas.openxmlformats.org/drawingml/2006/main" xmlns:r="http://schemas.openxmlformats.org/officeDocument/2006/relationships" xmlns:p="http://schemas.openxmlformats.org/presentationml/2006/main">
+  <p:cSld>
+    <p:spTree>
+      <p:nvGrpSpPr>
+        <p:cNvPr id="1" name=""/>
+        <p:cNvGrpSpPr/>
+        <p:nvPr/>
+      </p:nvGrpSpPr>
+      <p:grpSpPr>
+        <a:xfrm>
+          <a:off x="0" y="0"/>
+          <a:ext cx="0" cy="0"/>
+          <a:chOff x="0" y="0"/>
+          <a:chExt cx="0" cy="0"/>
+        </a:xfrm>
+      </p:grpSpPr>
+      <p:sp>
+        <p:nvSpPr>
+          <p:cNvPr id="2" name="Slide Image Placeholder 1"/>
+          <p:cNvSpPr>
+            <a:spLocks noGrp="1" noRot="1" noChangeAspect="1"/>
+          </p:cNvSpPr>
+          <p:nvPr>
+            <p:ph type="sldImg"/>
+          </p:nvPr>
+        </p:nvSpPr>
+        <p:spPr/>
+      </p:sp>
+      <p:sp>
+        <p:nvSpPr>
+          <p:cNvPr id="3" name="Notes Placeholder 2"/>
+          <p:cNvSpPr>
+            <a:spLocks noGrp="1"/>
+          </p:cNvSpPr>
+          <p:nvPr>
+            <p:ph type="body" idx="1"/>
+          </p:nvPr>
+        </p:nvSpPr>
+        <p:spPr/>
+        <p:txBody>
+          <a:bodyPr/>
+          <a:lstStyle/>
+          <a:p>
+            <a:r>
+              <a:rPr lang="en-US" dirty="0"/>
+              <a:t/>
+            </a:r>
+            <a:endParaRPr lang="en-US" dirty="0"/>
+          </a:p>
+        </p:txBody>
+      </p:sp>
+      <p:sp>
+        <p:nvSpPr>
+          <p:cNvPr id="4" name="Slide Number Placeholder 3"/>
+          <p:cNvSpPr>
+            <a:spLocks noGrp="1"/>
+          </p:cNvSpPr>
+          <p:nvPr>
+            <p:ph type="sldNum" sz="quarter" idx="10"/>
+          </p:nvPr>
+        </p:nvSpPr>
+        <p:spPr/>
+        <p:txBody>
+          <a:bodyPr/>
+          <a:lstStyle/>
+          <a:p>
+            <a:fld id="{F7021451-1387-4CA6-816F-3879F97B5CBC}" type="slidenum">
+              <a:rPr lang="en-US"/>
+              <a:t>35</a:t>
+            </a:fld>
+            <a:endParaRPr lang="en-US"/>
+          </a:p>
+        </p:txBody>
+      </p:sp>
+    </p:spTree>
+    <p:extLst>
+      <p:ext uri="{BB962C8B-B14F-4D97-AF65-F5344CB8AC3E}">
+        <p14:creationId xmlns:p14="http://schemas.microsoft.com/office/powerpoint/2010/main" val="1024086991"/>
+      </p:ext>
+    </p:extLst>
+  </p:cSld>
+  <p:clrMapOvr>
+    <a:masterClrMapping/>
+  </p:clrMapOvr>
+</p:notes>
+</file>
+
+<file path=ppt/notesSlides/notesSlide4.xml><?xml version="1.0" encoding="utf-8"?>
+<p:notes xmlns:a="http://schemas.openxmlformats.org/drawingml/2006/main" xmlns:r="http://schemas.openxmlformats.org/officeDocument/2006/relationships" xmlns:p="http://schemas.openxmlformats.org/presentationml/2006/main">
+  <p:cSld>
+    <p:spTree>
+      <p:nvGrpSpPr>
+        <p:cNvPr id="1" name=""/>
+        <p:cNvGrpSpPr/>
+        <p:nvPr/>
+      </p:nvGrpSpPr>
+      <p:grpSpPr>
+        <a:xfrm>
+          <a:off x="0" y="0"/>
+          <a:ext cx="0" cy="0"/>
+          <a:chOff x="0" y="0"/>
+          <a:chExt cx="0" cy="0"/>
+        </a:xfrm>
+      </p:grpSpPr>
+      <p:sp>
+        <p:nvSpPr>
+          <p:cNvPr id="2" name="Slide Image Placeholder 1"/>
+          <p:cNvSpPr>
+            <a:spLocks noGrp="1" noRot="1" noChangeAspect="1"/>
+          </p:cNvSpPr>
+          <p:nvPr>
+            <p:ph type="sldImg"/>
+          </p:nvPr>
+        </p:nvSpPr>
+        <p:spPr/>
+      </p:sp>
+      <p:sp>
+        <p:nvSpPr>
+          <p:cNvPr id="3" name="Notes Placeholder 2"/>
+          <p:cNvSpPr>
+            <a:spLocks noGrp="1"/>
+          </p:cNvSpPr>
+          <p:nvPr>
+            <p:ph type="body" idx="1"/>
+          </p:nvPr>
+        </p:nvSpPr>
+        <p:spPr/>
+        <p:txBody>
+          <a:bodyPr/>
+          <a:lstStyle/>
+          <a:p>
+            <a:r>
+              <a:rPr lang="en-US" dirty="0"/>
+              <a:t>The diagram before this drew three boxes. This is the same thing as a line,
+because the argument needs an order to point at.
+Five of the six were on that diagram. Step 5 is the one it does not draw, and
+the next slide is why.
+The number to land: exactly one of six belongs to the model. Ask for it out
+loud rather than saying it. At every other step the thing deciding what
+happens next is them, or a rule somebody wrote down in advance.</a:t>
+            </a:r>
+            <a:endParaRPr lang="en-US" dirty="0"/>
+          </a:p>
+        </p:txBody>
+      </p:sp>
+      <p:sp>
+        <p:nvSpPr>
+          <p:cNvPr id="4" name="Slide Number Placeholder 3"/>
+          <p:cNvSpPr>
+            <a:spLocks noGrp="1"/>
+          </p:cNvSpPr>
+          <p:nvPr>
+            <p:ph type="sldNum" sz="quarter" idx="10"/>
+          </p:nvPr>
+        </p:nvSpPr>
+        <p:spPr/>
+        <p:txBody>
+          <a:bodyPr/>
+          <a:lstStyle/>
+          <a:p>
+            <a:fld id="{F7021451-1387-4CA6-816F-3879F97B5CBC}" type="slidenum">
+              <a:rPr lang="en-US"/>
+              <a:t>4</a:t>
+            </a:fld>
+            <a:endParaRPr lang="en-US"/>
+          </a:p>
+        </p:txBody>
+      </p:sp>
+    </p:spTree>
+    <p:extLst>
+      <p:ext uri="{BB962C8B-B14F-4D97-AF65-F5344CB8AC3E}">
+        <p14:creationId xmlns:p14="http://schemas.microsoft.com/office/powerpoint/2010/main" val="1024086991"/>
+      </p:ext>
+    </p:extLst>
+  </p:cSld>
+  <p:clrMapOvr>
+    <a:masterClrMapping/>
+  </p:clrMapOvr>
+</p:notes>
+</file>
+
+<file path=ppt/notesSlides/notesSlide5.xml><?xml version="1.0" encoding="utf-8"?>
+<p:notes xmlns:a="http://schemas.openxmlformats.org/drawingml/2006/main" xmlns:r="http://schemas.openxmlformats.org/officeDocument/2006/relationships" xmlns:p="http://schemas.openxmlformats.org/presentationml/2006/main">
+  <p:cSld>
+    <p:spTree>
+      <p:nvGrpSpPr>
+        <p:cNvPr id="1" name=""/>
+        <p:cNvGrpSpPr/>
+        <p:nvPr/>
+      </p:nvGrpSpPr>
+      <p:grpSpPr>
+        <a:xfrm>
+          <a:off x="0" y="0"/>
+          <a:ext cx="0" cy="0"/>
+          <a:chOff x="0" y="0"/>
+          <a:chExt cx="0" cy="0"/>
+        </a:xfrm>
+      </p:grpSpPr>
+      <p:sp>
+        <p:nvSpPr>
+          <p:cNvPr id="2" name="Slide Image Placeholder 1"/>
+          <p:cNvSpPr>
+            <a:spLocks noGrp="1" noRot="1" noChangeAspect="1"/>
+          </p:cNvSpPr>
+          <p:nvPr>
+            <p:ph type="sldImg"/>
+          </p:nvPr>
+        </p:nvSpPr>
+        <p:spPr/>
+      </p:sp>
+      <p:sp>
+        <p:nvSpPr>
+          <p:cNvPr id="3" name="Notes Placeholder 2"/>
+          <p:cNvSpPr>
+            <a:spLocks noGrp="1"/>
+          </p:cNvSpPr>
+          <p:nvPr>
+            <p:ph type="body" idx="1"/>
+          </p:nvPr>
+        </p:nvSpPr>
+        <p:spPr/>
+        <p:txBody>
+          <a:bodyPr/>
+          <a:lstStyle/>
+          <a:p>
+            <a:r>
+              <a:rPr lang="en-US" dirty="0"/>
+              <a:t>Say this, in these words: a block that does not match is normal, not
+exceptional. The model quotes the lines it wants to replace, and the quote has
+to match the file exactly. One line it remembered wrong, and the block does not
+apply. Aider sends the miss back as the next prompt and runs step 2 again, up
+to three times, then it stops and tells you.
+This is the slide that keeps the "Aider has a loop" claim honest twenty
+minutes from now, so do not skip it.
+Repair is the only backward arrow in the whole sequence, which is why it was
+not on Lab01's diagram: three boxes left to right cannot draw it.
+The two things that make it a fixed loop rather than a decision: it always
+re-enters at the same step, and the repertoire it re-enters with is the same
+one it started with. Nothing new becomes possible on attempt two.
+Say the retry limit. Three, then it stops. A loop with a counter is still a
+loop, and it is still not choosing.</a:t>
+            </a:r>
+            <a:endParaRPr lang="en-US" dirty="0"/>
+          </a:p>
+        </p:txBody>
+      </p:sp>
+      <p:sp>
+        <p:nvSpPr>
+          <p:cNvPr id="4" name="Slide Number Placeholder 3"/>
+          <p:cNvSpPr>
+            <a:spLocks noGrp="1"/>
+          </p:cNvSpPr>
+          <p:nvPr>
+            <p:ph type="sldNum" sz="quarter" idx="10"/>
+          </p:nvPr>
+        </p:nvSpPr>
+        <p:spPr/>
+        <p:txBody>
+          <a:bodyPr/>
+          <a:lstStyle/>
+          <a:p>
+            <a:fld id="{F7021451-1387-4CA6-816F-3879F97B5CBC}" type="slidenum">
+              <a:rPr lang="en-US"/>
+              <a:t>5</a:t>
+            </a:fld>
+            <a:endParaRPr lang="en-US"/>
+          </a:p>
+        </p:txBody>
+      </p:sp>
+    </p:spTree>
+    <p:extLst>
+      <p:ext uri="{BB962C8B-B14F-4D97-AF65-F5344CB8AC3E}">
+        <p14:creationId xmlns:p14="http://schemas.microsoft.com/office/powerpoint/2010/main" val="1024086991"/>
+      </p:ext>
+    </p:extLst>
+  </p:cSld>
+  <p:clrMapOvr>
+    <a:masterClrMapping/>
+  </p:clrMapOvr>
+</p:notes>
+</file>
+
+<file path=ppt/notesSlides/notesSlide6.xml><?xml version="1.0" encoding="utf-8"?>
 <p:notes xmlns:a="http://schemas.openxmlformats.org/drawingml/2006/main" xmlns:r="http://schemas.openxmlformats.org/officeDocument/2006/relationships" xmlns:p="http://schemas.openxmlformats.org/presentationml/2006/main">
   <p:cSld>
     <p:spTree>
@@ -2549,7 +3384,7 @@
           <a:p>
             <a:fld id="{F7021451-1387-4CA6-816F-3879F97B5CBC}" type="slidenum">
               <a:rPr lang="en-US"/>
-              <a:t>3</a:t>
+              <a:t>6</a:t>
             </a:fld>
             <a:endParaRPr lang="en-US"/>
           </a:p>
@@ -2568,7 +3403,7 @@
 </p:notes>
 </file>
 
-<file path=ppt/notesSlides/notesSlide30.xml><?xml version="1.0" encoding="utf-8"?>
+<file path=ppt/notesSlides/notesSlide7.xml><?xml version="1.0" encoding="utf-8"?>
 <p:notes xmlns:a="http://schemas.openxmlformats.org/drawingml/2006/main" xmlns:r="http://schemas.openxmlformats.org/officeDocument/2006/relationships" xmlns:p="http://schemas.openxmlformats.org/presentationml/2006/main">
   <p:cSld>
     <p:spTree>
@@ -2614,9 +3449,7 @@
           <a:p>
             <a:r>
               <a:rPr lang="en-US" dirty="0"/>
-              <a:t>Leave this up during questions. Number two is the one that comes back in
-Analyze, and number three is the one that makes them better engineers this
-week.</a:t>
+              <a:t/>
             </a:r>
             <a:endParaRPr lang="en-US" dirty="0"/>
           </a:p>
@@ -2639,7 +3472,7 @@
           <a:p>
             <a:fld id="{F7021451-1387-4CA6-816F-3879F97B5CBC}" type="slidenum">
               <a:rPr lang="en-US"/>
-              <a:t>30</a:t>
+              <a:t>7</a:t>
             </a:fld>
             <a:endParaRPr lang="en-US"/>
           </a:p>
@@ -2658,7 +3491,7 @@
 </p:notes>
 </file>
 
-<file path=ppt/notesSlides/notesSlide31.xml><?xml version="1.0" encoding="utf-8"?>
+<file path=ppt/notesSlides/notesSlide8.xml><?xml version="1.0" encoding="utf-8"?>
 <p:notes xmlns:a="http://schemas.openxmlformats.org/drawingml/2006/main" xmlns:r="http://schemas.openxmlformats.org/officeDocument/2006/relationships" xmlns:p="http://schemas.openxmlformats.org/presentationml/2006/main">
   <p:cSld>
     <p:spTree>
@@ -2704,8 +3537,16 @@
           <a:p>
             <a:r>
               <a:rPr lang="en-US" dirty="0"/>
-              <a:t>The bridge. L06 closes Apply and hands over to Analyze, where they write the
-box from the harness slide rather than watching it work.</a:t>
+              <a:t>Walk up it once, fast, one sentence each. The detail is in content.md and they
+do not need all of it.
+The dashed line is the slide. Rungs 1 to 3 differ in how much they automate.
+Rung 4 differs in who decides. That is a change of kind, not of degree.
+Lab01 names three milestones for the build: M1 pair-programmer, M2 agent, M3
+assistant. Those are the shapes one repository passes through; the rungs are
+where any tool sits. M1 is rung 3, M2 crosses the dashed line to rung 4, M3
+stays there and hardens it. Say it once so the two ladders do not compete.
+Monday's room heard the older closing without the milestone names, so say
+them as if new.</a:t>
             </a:r>
             <a:endParaRPr lang="en-US" dirty="0"/>
           </a:p>
@@ -2728,7 +3569,7 @@
           <a:p>
             <a:fld id="{F7021451-1387-4CA6-816F-3879F97B5CBC}" type="slidenum">
               <a:rPr lang="en-US"/>
-              <a:t>31</a:t>
+              <a:t>8</a:t>
             </a:fld>
             <a:endParaRPr lang="en-US"/>
           </a:p>
@@ -2747,274 +3588,7 @@
 </p:notes>
 </file>
 
-<file path=ppt/notesSlides/notesSlide32.xml><?xml version="1.0" encoding="utf-8"?>
-<p:notes xmlns:a="http://schemas.openxmlformats.org/drawingml/2006/main" xmlns:r="http://schemas.openxmlformats.org/officeDocument/2006/relationships" xmlns:p="http://schemas.openxmlformats.org/presentationml/2006/main">
-  <p:cSld>
-    <p:spTree>
-      <p:nvGrpSpPr>
-        <p:cNvPr id="1" name=""/>
-        <p:cNvGrpSpPr/>
-        <p:nvPr/>
-      </p:nvGrpSpPr>
-      <p:grpSpPr>
-        <a:xfrm>
-          <a:off x="0" y="0"/>
-          <a:ext cx="0" cy="0"/>
-          <a:chOff x="0" y="0"/>
-          <a:chExt cx="0" cy="0"/>
-        </a:xfrm>
-      </p:grpSpPr>
-      <p:sp>
-        <p:nvSpPr>
-          <p:cNvPr id="2" name="Slide Image Placeholder 1"/>
-          <p:cNvSpPr>
-            <a:spLocks noGrp="1" noRot="1" noChangeAspect="1"/>
-          </p:cNvSpPr>
-          <p:nvPr>
-            <p:ph type="sldImg"/>
-          </p:nvPr>
-        </p:nvSpPr>
-        <p:spPr/>
-      </p:sp>
-      <p:sp>
-        <p:nvSpPr>
-          <p:cNvPr id="3" name="Notes Placeholder 2"/>
-          <p:cNvSpPr>
-            <a:spLocks noGrp="1"/>
-          </p:cNvSpPr>
-          <p:nvPr>
-            <p:ph type="body" idx="1"/>
-          </p:nvPr>
-        </p:nvSpPr>
-        <p:spPr/>
-        <p:txBody>
-          <a:bodyPr/>
-          <a:lstStyle/>
-          <a:p>
-            <a:r>
-              <a:rPr lang="en-US" dirty="0"/>
-              <a:t/>
-            </a:r>
-            <a:endParaRPr lang="en-US" dirty="0"/>
-          </a:p>
-        </p:txBody>
-      </p:sp>
-      <p:sp>
-        <p:nvSpPr>
-          <p:cNvPr id="4" name="Slide Number Placeholder 3"/>
-          <p:cNvSpPr>
-            <a:spLocks noGrp="1"/>
-          </p:cNvSpPr>
-          <p:nvPr>
-            <p:ph type="sldNum" sz="quarter" idx="10"/>
-          </p:nvPr>
-        </p:nvSpPr>
-        <p:spPr/>
-        <p:txBody>
-          <a:bodyPr/>
-          <a:lstStyle/>
-          <a:p>
-            <a:fld id="{F7021451-1387-4CA6-816F-3879F97B5CBC}" type="slidenum">
-              <a:rPr lang="en-US"/>
-              <a:t>32</a:t>
-            </a:fld>
-            <a:endParaRPr lang="en-US"/>
-          </a:p>
-        </p:txBody>
-      </p:sp>
-    </p:spTree>
-    <p:extLst>
-      <p:ext uri="{BB962C8B-B14F-4D97-AF65-F5344CB8AC3E}">
-        <p14:creationId xmlns:p14="http://schemas.microsoft.com/office/powerpoint/2010/main" val="1024086991"/>
-      </p:ext>
-    </p:extLst>
-  </p:cSld>
-  <p:clrMapOvr>
-    <a:masterClrMapping/>
-  </p:clrMapOvr>
-</p:notes>
-</file>
-
-<file path=ppt/notesSlides/notesSlide4.xml><?xml version="1.0" encoding="utf-8"?>
-<p:notes xmlns:a="http://schemas.openxmlformats.org/drawingml/2006/main" xmlns:r="http://schemas.openxmlformats.org/officeDocument/2006/relationships" xmlns:p="http://schemas.openxmlformats.org/presentationml/2006/main">
-  <p:cSld>
-    <p:spTree>
-      <p:nvGrpSpPr>
-        <p:cNvPr id="1" name=""/>
-        <p:cNvGrpSpPr/>
-        <p:nvPr/>
-      </p:nvGrpSpPr>
-      <p:grpSpPr>
-        <a:xfrm>
-          <a:off x="0" y="0"/>
-          <a:ext cx="0" cy="0"/>
-          <a:chOff x="0" y="0"/>
-          <a:chExt cx="0" cy="0"/>
-        </a:xfrm>
-      </p:grpSpPr>
-      <p:sp>
-        <p:nvSpPr>
-          <p:cNvPr id="2" name="Slide Image Placeholder 1"/>
-          <p:cNvSpPr>
-            <a:spLocks noGrp="1" noRot="1" noChangeAspect="1"/>
-          </p:cNvSpPr>
-          <p:nvPr>
-            <p:ph type="sldImg"/>
-          </p:nvPr>
-        </p:nvSpPr>
-        <p:spPr/>
-      </p:sp>
-      <p:sp>
-        <p:nvSpPr>
-          <p:cNvPr id="3" name="Notes Placeholder 2"/>
-          <p:cNvSpPr>
-            <a:spLocks noGrp="1"/>
-          </p:cNvSpPr>
-          <p:nvPr>
-            <p:ph type="body" idx="1"/>
-          </p:nvPr>
-        </p:nvSpPr>
-        <p:spPr/>
-        <p:txBody>
-          <a:bodyPr/>
-          <a:lstStyle/>
-          <a:p>
-            <a:r>
-              <a:rPr lang="en-US" dirty="0"/>
-              <a:t/>
-            </a:r>
-            <a:endParaRPr lang="en-US" dirty="0"/>
-          </a:p>
-        </p:txBody>
-      </p:sp>
-      <p:sp>
-        <p:nvSpPr>
-          <p:cNvPr id="4" name="Slide Number Placeholder 3"/>
-          <p:cNvSpPr>
-            <a:spLocks noGrp="1"/>
-          </p:cNvSpPr>
-          <p:nvPr>
-            <p:ph type="sldNum" sz="quarter" idx="10"/>
-          </p:nvPr>
-        </p:nvSpPr>
-        <p:spPr/>
-        <p:txBody>
-          <a:bodyPr/>
-          <a:lstStyle/>
-          <a:p>
-            <a:fld id="{F7021451-1387-4CA6-816F-3879F97B5CBC}" type="slidenum">
-              <a:rPr lang="en-US"/>
-              <a:t>4</a:t>
-            </a:fld>
-            <a:endParaRPr lang="en-US"/>
-          </a:p>
-        </p:txBody>
-      </p:sp>
-    </p:spTree>
-    <p:extLst>
-      <p:ext uri="{BB962C8B-B14F-4D97-AF65-F5344CB8AC3E}">
-        <p14:creationId xmlns:p14="http://schemas.microsoft.com/office/powerpoint/2010/main" val="1024086991"/>
-      </p:ext>
-    </p:extLst>
-  </p:cSld>
-  <p:clrMapOvr>
-    <a:masterClrMapping/>
-  </p:clrMapOvr>
-</p:notes>
-</file>
-
-<file path=ppt/notesSlides/notesSlide5.xml><?xml version="1.0" encoding="utf-8"?>
-<p:notes xmlns:a="http://schemas.openxmlformats.org/drawingml/2006/main" xmlns:r="http://schemas.openxmlformats.org/officeDocument/2006/relationships" xmlns:p="http://schemas.openxmlformats.org/presentationml/2006/main">
-  <p:cSld>
-    <p:spTree>
-      <p:nvGrpSpPr>
-        <p:cNvPr id="1" name=""/>
-        <p:cNvGrpSpPr/>
-        <p:nvPr/>
-      </p:nvGrpSpPr>
-      <p:grpSpPr>
-        <a:xfrm>
-          <a:off x="0" y="0"/>
-          <a:ext cx="0" cy="0"/>
-          <a:chOff x="0" y="0"/>
-          <a:chExt cx="0" cy="0"/>
-        </a:xfrm>
-      </p:grpSpPr>
-      <p:sp>
-        <p:nvSpPr>
-          <p:cNvPr id="2" name="Slide Image Placeholder 1"/>
-          <p:cNvSpPr>
-            <a:spLocks noGrp="1" noRot="1" noChangeAspect="1"/>
-          </p:cNvSpPr>
-          <p:nvPr>
-            <p:ph type="sldImg"/>
-          </p:nvPr>
-        </p:nvSpPr>
-        <p:spPr/>
-      </p:sp>
-      <p:sp>
-        <p:nvSpPr>
-          <p:cNvPr id="3" name="Notes Placeholder 2"/>
-          <p:cNvSpPr>
-            <a:spLocks noGrp="1"/>
-          </p:cNvSpPr>
-          <p:nvPr>
-            <p:ph type="body" idx="1"/>
-          </p:nvPr>
-        </p:nvSpPr>
-        <p:spPr/>
-        <p:txBody>
-          <a:bodyPr/>
-          <a:lstStyle/>
-          <a:p>
-            <a:r>
-              <a:rPr lang="en-US" dirty="0"/>
-              <a:t>Walk up it once, fast, one sentence each. The detail is in content.md and they
-do not need all of it.
-The dashed line is the slide. Rungs 1 to 3 differ in how much they automate.
-Rung 4 differs in who decides. That is a change of kind, not of degree.</a:t>
-            </a:r>
-            <a:endParaRPr lang="en-US" dirty="0"/>
-          </a:p>
-        </p:txBody>
-      </p:sp>
-      <p:sp>
-        <p:nvSpPr>
-          <p:cNvPr id="4" name="Slide Number Placeholder 3"/>
-          <p:cNvSpPr>
-            <a:spLocks noGrp="1"/>
-          </p:cNvSpPr>
-          <p:nvPr>
-            <p:ph type="sldNum" sz="quarter" idx="10"/>
-          </p:nvPr>
-        </p:nvSpPr>
-        <p:spPr/>
-        <p:txBody>
-          <a:bodyPr/>
-          <a:lstStyle/>
-          <a:p>
-            <a:fld id="{F7021451-1387-4CA6-816F-3879F97B5CBC}" type="slidenum">
-              <a:rPr lang="en-US"/>
-              <a:t>5</a:t>
-            </a:fld>
-            <a:endParaRPr lang="en-US"/>
-          </a:p>
-        </p:txBody>
-      </p:sp>
-    </p:spTree>
-    <p:extLst>
-      <p:ext uri="{BB962C8B-B14F-4D97-AF65-F5344CB8AC3E}">
-        <p14:creationId xmlns:p14="http://schemas.microsoft.com/office/powerpoint/2010/main" val="1024086991"/>
-      </p:ext>
-    </p:extLst>
-  </p:cSld>
-  <p:clrMapOvr>
-    <a:masterClrMapping/>
-  </p:clrMapOvr>
-</p:notes>
-</file>
-
-<file path=ppt/notesSlides/notesSlide6.xml><?xml version="1.0" encoding="utf-8"?>
+<file path=ppt/notesSlides/notesSlide9.xml><?xml version="1.0" encoding="utf-8"?>
 <p:notes xmlns:a="http://schemas.openxmlformats.org/drawingml/2006/main" xmlns:r="http://schemas.openxmlformats.org/officeDocument/2006/relationships" xmlns:p="http://schemas.openxmlformats.org/presentationml/2006/main">
   <p:cSld>
     <p:spTree>
@@ -3064,275 +3638,6 @@
 and commits. What it does not do is pick the next task.
 If someone says "so Aider is not agentic," push back: it has the parts, and we
 are about to check that claim properly.</a:t>
-            </a:r>
-            <a:endParaRPr lang="en-US" dirty="0"/>
-          </a:p>
-        </p:txBody>
-      </p:sp>
-      <p:sp>
-        <p:nvSpPr>
-          <p:cNvPr id="4" name="Slide Number Placeholder 3"/>
-          <p:cNvSpPr>
-            <a:spLocks noGrp="1"/>
-          </p:cNvSpPr>
-          <p:nvPr>
-            <p:ph type="sldNum" sz="quarter" idx="10"/>
-          </p:nvPr>
-        </p:nvSpPr>
-        <p:spPr/>
-        <p:txBody>
-          <a:bodyPr/>
-          <a:lstStyle/>
-          <a:p>
-            <a:fld id="{F7021451-1387-4CA6-816F-3879F97B5CBC}" type="slidenum">
-              <a:rPr lang="en-US"/>
-              <a:t>6</a:t>
-            </a:fld>
-            <a:endParaRPr lang="en-US"/>
-          </a:p>
-        </p:txBody>
-      </p:sp>
-    </p:spTree>
-    <p:extLst>
-      <p:ext uri="{BB962C8B-B14F-4D97-AF65-F5344CB8AC3E}">
-        <p14:creationId xmlns:p14="http://schemas.microsoft.com/office/powerpoint/2010/main" val="1024086991"/>
-      </p:ext>
-    </p:extLst>
-  </p:cSld>
-  <p:clrMapOvr>
-    <a:masterClrMapping/>
-  </p:clrMapOvr>
-</p:notes>
-</file>
-
-<file path=ppt/notesSlides/notesSlide7.xml><?xml version="1.0" encoding="utf-8"?>
-<p:notes xmlns:a="http://schemas.openxmlformats.org/drawingml/2006/main" xmlns:r="http://schemas.openxmlformats.org/officeDocument/2006/relationships" xmlns:p="http://schemas.openxmlformats.org/presentationml/2006/main">
-  <p:cSld>
-    <p:spTree>
-      <p:nvGrpSpPr>
-        <p:cNvPr id="1" name=""/>
-        <p:cNvGrpSpPr/>
-        <p:nvPr/>
-      </p:nvGrpSpPr>
-      <p:grpSpPr>
-        <a:xfrm>
-          <a:off x="0" y="0"/>
-          <a:ext cx="0" cy="0"/>
-          <a:chOff x="0" y="0"/>
-          <a:chExt cx="0" cy="0"/>
-        </a:xfrm>
-      </p:grpSpPr>
-      <p:sp>
-        <p:nvSpPr>
-          <p:cNvPr id="2" name="Slide Image Placeholder 1"/>
-          <p:cNvSpPr>
-            <a:spLocks noGrp="1" noRot="1" noChangeAspect="1"/>
-          </p:cNvSpPr>
-          <p:nvPr>
-            <p:ph type="sldImg"/>
-          </p:nvPr>
-        </p:nvSpPr>
-        <p:spPr/>
-      </p:sp>
-      <p:sp>
-        <p:nvSpPr>
-          <p:cNvPr id="3" name="Notes Placeholder 2"/>
-          <p:cNvSpPr>
-            <a:spLocks noGrp="1"/>
-          </p:cNvSpPr>
-          <p:nvPr>
-            <p:ph type="body" idx="1"/>
-          </p:nvPr>
-        </p:nvSpPr>
-        <p:spPr/>
-        <p:txBody>
-          <a:bodyPr/>
-          <a:lstStyle/>
-          <a:p>
-            <a:r>
-              <a:rPr lang="en-US" dirty="0"/>
-              <a:t>This trade is the entire gradient. Everything else is detail.
-Do not quantify it. Any multiple you say out loud will be wrong by next month
-and somebody will quote it back to you.</a:t>
-            </a:r>
-            <a:endParaRPr lang="en-US" dirty="0"/>
-          </a:p>
-        </p:txBody>
-      </p:sp>
-      <p:sp>
-        <p:nvSpPr>
-          <p:cNvPr id="4" name="Slide Number Placeholder 3"/>
-          <p:cNvSpPr>
-            <a:spLocks noGrp="1"/>
-          </p:cNvSpPr>
-          <p:nvPr>
-            <p:ph type="sldNum" sz="quarter" idx="10"/>
-          </p:nvPr>
-        </p:nvSpPr>
-        <p:spPr/>
-        <p:txBody>
-          <a:bodyPr/>
-          <a:lstStyle/>
-          <a:p>
-            <a:fld id="{F7021451-1387-4CA6-816F-3879F97B5CBC}" type="slidenum">
-              <a:rPr lang="en-US"/>
-              <a:t>7</a:t>
-            </a:fld>
-            <a:endParaRPr lang="en-US"/>
-          </a:p>
-        </p:txBody>
-      </p:sp>
-    </p:spTree>
-    <p:extLst>
-      <p:ext uri="{BB962C8B-B14F-4D97-AF65-F5344CB8AC3E}">
-        <p14:creationId xmlns:p14="http://schemas.microsoft.com/office/powerpoint/2010/main" val="1024086991"/>
-      </p:ext>
-    </p:extLst>
-  </p:cSld>
-  <p:clrMapOvr>
-    <a:masterClrMapping/>
-  </p:clrMapOvr>
-</p:notes>
-</file>
-
-<file path=ppt/notesSlides/notesSlide8.xml><?xml version="1.0" encoding="utf-8"?>
-<p:notes xmlns:a="http://schemas.openxmlformats.org/drawingml/2006/main" xmlns:r="http://schemas.openxmlformats.org/officeDocument/2006/relationships" xmlns:p="http://schemas.openxmlformats.org/presentationml/2006/main">
-  <p:cSld>
-    <p:spTree>
-      <p:nvGrpSpPr>
-        <p:cNvPr id="1" name=""/>
-        <p:cNvGrpSpPr/>
-        <p:nvPr/>
-      </p:nvGrpSpPr>
-      <p:grpSpPr>
-        <a:xfrm>
-          <a:off x="0" y="0"/>
-          <a:ext cx="0" cy="0"/>
-          <a:chOff x="0" y="0"/>
-          <a:chExt cx="0" cy="0"/>
-        </a:xfrm>
-      </p:grpSpPr>
-      <p:sp>
-        <p:nvSpPr>
-          <p:cNvPr id="2" name="Slide Image Placeholder 1"/>
-          <p:cNvSpPr>
-            <a:spLocks noGrp="1" noRot="1" noChangeAspect="1"/>
-          </p:cNvSpPr>
-          <p:nvPr>
-            <p:ph type="sldImg"/>
-          </p:nvPr>
-        </p:nvSpPr>
-        <p:spPr/>
-      </p:sp>
-      <p:sp>
-        <p:nvSpPr>
-          <p:cNvPr id="3" name="Notes Placeholder 2"/>
-          <p:cNvSpPr>
-            <a:spLocks noGrp="1"/>
-          </p:cNvSpPr>
-          <p:nvPr>
-            <p:ph type="body" idx="1"/>
-          </p:nvPr>
-        </p:nvSpPr>
-        <p:spPr/>
-        <p:txBody>
-          <a:bodyPr/>
-          <a:lstStyle/>
-          <a:p>
-            <a:r>
-              <a:rPr lang="en-US" dirty="0"/>
-              <a:t>The reflex this is aimed at: reaching for the most autonomous tool available
-because it is the most autonomous tool available.
-Ask when they would rather have the bounded version. Answers you are hoping
-for involve knowing exactly what to change, or a blast radius they care about.</a:t>
-            </a:r>
-            <a:endParaRPr lang="en-US" dirty="0"/>
-          </a:p>
-        </p:txBody>
-      </p:sp>
-      <p:sp>
-        <p:nvSpPr>
-          <p:cNvPr id="4" name="Slide Number Placeholder 3"/>
-          <p:cNvSpPr>
-            <a:spLocks noGrp="1"/>
-          </p:cNvSpPr>
-          <p:nvPr>
-            <p:ph type="sldNum" sz="quarter" idx="10"/>
-          </p:nvPr>
-        </p:nvSpPr>
-        <p:spPr/>
-        <p:txBody>
-          <a:bodyPr/>
-          <a:lstStyle/>
-          <a:p>
-            <a:fld id="{F7021451-1387-4CA6-816F-3879F97B5CBC}" type="slidenum">
-              <a:rPr lang="en-US"/>
-              <a:t>8</a:t>
-            </a:fld>
-            <a:endParaRPr lang="en-US"/>
-          </a:p>
-        </p:txBody>
-      </p:sp>
-    </p:spTree>
-    <p:extLst>
-      <p:ext uri="{BB962C8B-B14F-4D97-AF65-F5344CB8AC3E}">
-        <p14:creationId xmlns:p14="http://schemas.microsoft.com/office/powerpoint/2010/main" val="1024086991"/>
-      </p:ext>
-    </p:extLst>
-  </p:cSld>
-  <p:clrMapOvr>
-    <a:masterClrMapping/>
-  </p:clrMapOvr>
-</p:notes>
-</file>
-
-<file path=ppt/notesSlides/notesSlide9.xml><?xml version="1.0" encoding="utf-8"?>
-<p:notes xmlns:a="http://schemas.openxmlformats.org/drawingml/2006/main" xmlns:r="http://schemas.openxmlformats.org/officeDocument/2006/relationships" xmlns:p="http://schemas.openxmlformats.org/presentationml/2006/main">
-  <p:cSld>
-    <p:spTree>
-      <p:nvGrpSpPr>
-        <p:cNvPr id="1" name=""/>
-        <p:cNvGrpSpPr/>
-        <p:nvPr/>
-      </p:nvGrpSpPr>
-      <p:grpSpPr>
-        <a:xfrm>
-          <a:off x="0" y="0"/>
-          <a:ext cx="0" cy="0"/>
-          <a:chOff x="0" y="0"/>
-          <a:chExt cx="0" cy="0"/>
-        </a:xfrm>
-      </p:grpSpPr>
-      <p:sp>
-        <p:nvSpPr>
-          <p:cNvPr id="2" name="Slide Image Placeholder 1"/>
-          <p:cNvSpPr>
-            <a:spLocks noGrp="1" noRot="1" noChangeAspect="1"/>
-          </p:cNvSpPr>
-          <p:nvPr>
-            <p:ph type="sldImg"/>
-          </p:nvPr>
-        </p:nvSpPr>
-        <p:spPr/>
-      </p:sp>
-      <p:sp>
-        <p:nvSpPr>
-          <p:cNvPr id="3" name="Notes Placeholder 2"/>
-          <p:cNvSpPr>
-            <a:spLocks noGrp="1"/>
-          </p:cNvSpPr>
-          <p:nvPr>
-            <p:ph type="body" idx="1"/>
-          </p:nvPr>
-        </p:nvSpPr>
-        <p:spPr/>
-        <p:txBody>
-          <a:bodyPr/>
-          <a:lstStyle/>
-          <a:p>
-            <a:r>
-              <a:rPr lang="en-US" dirty="0"/>
-              <a:t/>
             </a:r>
             <a:endParaRPr lang="en-US" dirty="0"/>
           </a:p>
@@ -4659,6 +4964,123 @@
 <file path=ppt/slides/slide32.xml><?xml version="1.0" encoding="utf-8"?>
 <p:sld xmlns:a="http://schemas.openxmlformats.org/drawingml/2006/main" xmlns:r="http://schemas.openxmlformats.org/officeDocument/2006/relationships" xmlns:p="http://schemas.openxmlformats.org/presentationml/2006/main">
   <p:cSld name="Slide 32">
+    <p:bg>
+      <p:bgPr>
+        <a:blipFill dpi="0" rotWithShape="1">
+          <a:blip r:embed="rId1">
+            <a:lum/>
+          </a:blip>
+          <a:srcRect/>
+          <a:stretch>
+            <a:fillRect/>
+          </a:stretch>
+        </a:blipFill>
+        <a:effectLst/>
+      </p:bgPr>
+    </p:bg>
+    <p:spTree>
+      <p:nvGrpSpPr>
+        <p:cNvPr id="1" name=""/>
+        <p:cNvGrpSpPr/>
+        <p:nvPr/>
+      </p:nvGrpSpPr>
+      <p:grpSpPr>
+        <a:xfrm>
+          <a:off x="0" y="0"/>
+          <a:ext cx="0" cy="0"/>
+          <a:chOff x="0" y="0"/>
+          <a:chExt cx="0" cy="0"/>
+        </a:xfrm>
+      </p:grpSpPr>
+    </p:spTree>
+  </p:cSld>
+  <p:clrMapOvr>
+    <a:masterClrMapping/>
+  </p:clrMapOvr>
+</p:sld>
+</file>
+
+<file path=ppt/slides/slide33.xml><?xml version="1.0" encoding="utf-8"?>
+<p:sld xmlns:a="http://schemas.openxmlformats.org/drawingml/2006/main" xmlns:r="http://schemas.openxmlformats.org/officeDocument/2006/relationships" xmlns:p="http://schemas.openxmlformats.org/presentationml/2006/main">
+  <p:cSld name="Slide 33">
+    <p:bg>
+      <p:bgPr>
+        <a:blipFill dpi="0" rotWithShape="1">
+          <a:blip r:embed="rId1">
+            <a:lum/>
+          </a:blip>
+          <a:srcRect/>
+          <a:stretch>
+            <a:fillRect/>
+          </a:stretch>
+        </a:blipFill>
+        <a:effectLst/>
+      </p:bgPr>
+    </p:bg>
+    <p:spTree>
+      <p:nvGrpSpPr>
+        <p:cNvPr id="1" name=""/>
+        <p:cNvGrpSpPr/>
+        <p:nvPr/>
+      </p:nvGrpSpPr>
+      <p:grpSpPr>
+        <a:xfrm>
+          <a:off x="0" y="0"/>
+          <a:ext cx="0" cy="0"/>
+          <a:chOff x="0" y="0"/>
+          <a:chExt cx="0" cy="0"/>
+        </a:xfrm>
+      </p:grpSpPr>
+    </p:spTree>
+  </p:cSld>
+  <p:clrMapOvr>
+    <a:masterClrMapping/>
+  </p:clrMapOvr>
+</p:sld>
+</file>
+
+<file path=ppt/slides/slide34.xml><?xml version="1.0" encoding="utf-8"?>
+<p:sld xmlns:a="http://schemas.openxmlformats.org/drawingml/2006/main" xmlns:r="http://schemas.openxmlformats.org/officeDocument/2006/relationships" xmlns:p="http://schemas.openxmlformats.org/presentationml/2006/main">
+  <p:cSld name="Slide 34">
+    <p:bg>
+      <p:bgPr>
+        <a:blipFill dpi="0" rotWithShape="1">
+          <a:blip r:embed="rId1">
+            <a:lum/>
+          </a:blip>
+          <a:srcRect/>
+          <a:stretch>
+            <a:fillRect/>
+          </a:stretch>
+        </a:blipFill>
+        <a:effectLst/>
+      </p:bgPr>
+    </p:bg>
+    <p:spTree>
+      <p:nvGrpSpPr>
+        <p:cNvPr id="1" name=""/>
+        <p:cNvGrpSpPr/>
+        <p:nvPr/>
+      </p:nvGrpSpPr>
+      <p:grpSpPr>
+        <a:xfrm>
+          <a:off x="0" y="0"/>
+          <a:ext cx="0" cy="0"/>
+          <a:chOff x="0" y="0"/>
+          <a:chExt cx="0" cy="0"/>
+        </a:xfrm>
+      </p:grpSpPr>
+    </p:spTree>
+  </p:cSld>
+  <p:clrMapOvr>
+    <a:masterClrMapping/>
+  </p:clrMapOvr>
+</p:sld>
+</file>
+
+<file path=ppt/slides/slide35.xml><?xml version="1.0" encoding="utf-8"?>
+<p:sld xmlns:a="http://schemas.openxmlformats.org/drawingml/2006/main" xmlns:r="http://schemas.openxmlformats.org/officeDocument/2006/relationships" xmlns:p="http://schemas.openxmlformats.org/presentationml/2006/main">
+  <p:cSld name="Slide 35">
     <p:bg>
       <p:bgPr>
         <a:blipFill dpi="0" rotWithShape="1">

</xml_diff>